<commit_message>
docs: update presentation + add build workflow doc
Slide 3 — Results:
- Headline: "Shipped. Debugged. No shortcuts."
- Stat: "3 prod bugs fixed" → "6 bugs resolved" (reflects full debug journey)
- Deliverables: updated to mention Supabase PostgREST direct blog path
- Quote: updated to match blog's three-root-cause conclusion

workflow.md (new — Deliverable C item 1):
- Day-by-day step-by-step account of the full build
- Each bug documented with root cause and precise fix
- Required by Task 01 brief alongside prompt-log, tech-stack, hosting, database docs

Blog post updated in Supabase (not a file change):
- Added "The Blog Section That Refused to Show" chapter
- Documents all three layers: CORS, invisible cards, Vercel proxy timeout
- Updated excerpt to reflect expanded scope

Co-Authored-By: Claude Sonnet 4.6 <noreply@anthropic.com>
</commit_message>
<xml_diff>
--- a/docs/task01-presentation.pptx
+++ b/docs/task01-presentation.pptx
@@ -4785,7 +4785,7 @@
                 </a:solidFill>
                 <a:latin typeface="Georgia"/>
               </a:rPr>
-              <a:t>Shipped. Deployed. No shortcuts.</a:t>
+              <a:t>Shipped. Debugged. No shortcuts.</a:t>
             </a:r>
           </a:p>
         </p:txBody>
@@ -5210,7 +5210,7 @@
                 </a:solidFill>
                 <a:latin typeface="Georgia"/>
               </a:rPr>
-              <a:t>3</a:t>
+              <a:t>6</a:t>
             </a:r>
           </a:p>
         </p:txBody>
@@ -5245,7 +5245,7 @@
                 </a:solidFill>
                 <a:latin typeface="Calibri"/>
               </a:rPr>
-              <a:t>prod bugs fixed</a:t>
+              <a:t>bugs resolved</a:t>
             </a:r>
           </a:p>
         </p:txBody>
@@ -5284,7 +5284,7 @@
                 </a:solidFill>
                 <a:latin typeface="Calibri"/>
               </a:rPr>
-              <a:t>•  React 18 + TypeScript frontend deployed on Vercel</a:t>
+              <a:t>•  React 18 + TypeScript frontend — Vercel</a:t>
             </a:r>
           </a:p>
           <a:p>
@@ -5300,7 +5300,7 @@
                 </a:solidFill>
                 <a:latin typeface="Calibri"/>
               </a:rPr>
-              <a:t>•  ASP.NET Core 9 Clean Architecture API on Render</a:t>
+              <a:t>•  ASP.NET Core 9 Clean Architecture API — Render</a:t>
             </a:r>
           </a:p>
           <a:p>
@@ -5316,7 +5316,7 @@
                 </a:solidFill>
                 <a:latin typeface="Calibri"/>
               </a:rPr>
-              <a:t>•  Supabase PostgreSQL — contact form + blog database</a:t>
+              <a:t>•  Blog data served direct from Supabase PostgREST</a:t>
             </a:r>
           </a:p>
           <a:p>
@@ -5332,7 +5332,7 @@
                 </a:solidFill>
                 <a:latin typeface="Calibri"/>
               </a:rPr>
-              <a:t>•  JWT admin panel  ·  Blog article published live</a:t>
+              <a:t>•  JWT admin panel  ·  Blog article live + debugged</a:t>
             </a:r>
           </a:p>
         </p:txBody>
@@ -5534,7 +5534,7 @@
                 </a:solidFill>
                 <a:latin typeface="Georgia"/>
               </a:rPr>
-              <a:t>"The tool is not the variable.</a:t>
+              <a:t>"Three root causes.</a:t>
             </a:r>
           </a:p>
           <a:p>
@@ -5545,7 +5545,18 @@
                 </a:solidFill>
                 <a:latin typeface="Georgia"/>
               </a:rPr>
-              <a:t>The discipline is."</a:t>
+              <a:t>Three precise fixes.</a:t>
+            </a:r>
+          </a:p>
+          <a:p>
+            <a:r>
+              <a:rPr sz="1250" i="1">
+                <a:solidFill>
+                  <a:srgbClr val="F0F0F0"/>
+                </a:solidFill>
+                <a:latin typeface="Georgia"/>
+              </a:rPr>
+              <a:t>None visible by reading code alone."</a:t>
             </a:r>
           </a:p>
         </p:txBody>

</xml_diff>

<commit_message>
fix(pptx): fix slide 3 headline overflow causing PowerPoint misrender
Root cause: 34pt Georgia headline wrapped to 2 lines and collided with
stat cards at y=1.5". PowerPoint misrendered the slide when content
overflowed the text box into adjacent shapes.

Fixes:
- Reduced headline font 34pt → 28pt (single line, no collision)
- Moved stat cards from y=1.5" to y=1.3" for tighter layout
- Added explicit grpSpPr xfrm (chOff/chExt) to all slides — required
  by OOXML spec, omitted by python-pptx, tolerated by LibreOffice
  but not always by PowerPoint on shape-dense slides

Verified all 3 slides correct via LibreOffice PNG render before commit.

Co-Authored-By: Claude Sonnet 4.6 <noreply@anthropic.com>
</commit_message>
<xml_diff>
--- a/docs/task01-presentation.pptx
+++ b/docs/task01-presentation.pptx
@@ -3097,7 +3097,14 @@
         <p:cNvGrpSpPr/>
         <p:nvPr/>
       </p:nvGrpSpPr>
-      <p:grpSpPr/>
+      <p:grpSpPr>
+        <a:xfrm>
+          <a:off x="0" y="0"/>
+          <a:ext cx="9144000" cy="5143500"/>
+          <a:chOff x="0" y="0"/>
+          <a:chExt cx="9144000" cy="5143500"/>
+        </a:xfrm>
+      </p:grpSpPr>
       <p:sp>
         <p:nvSpPr>
           <p:cNvPr id="2" name="Rectangle 1"/>
@@ -3958,7 +3965,14 @@
         <p:cNvGrpSpPr/>
         <p:nvPr/>
       </p:nvGrpSpPr>
-      <p:grpSpPr/>
+      <p:grpSpPr>
+        <a:xfrm>
+          <a:off x="0" y="0"/>
+          <a:ext cx="9144000" cy="5143500"/>
+          <a:chOff x="0" y="0"/>
+          <a:chExt cx="9144000" cy="5143500"/>
+        </a:xfrm>
+      </p:grpSpPr>
       <p:sp>
         <p:nvSpPr>
           <p:cNvPr id="2" name="Rectangle 1"/>
@@ -4633,7 +4647,14 @@
         <p:cNvGrpSpPr/>
         <p:nvPr/>
       </p:nvGrpSpPr>
-      <p:grpSpPr/>
+      <p:grpSpPr>
+        <a:xfrm>
+          <a:off x="0" y="0"/>
+          <a:ext cx="9144000" cy="5143500"/>
+          <a:chOff x="0" y="0"/>
+          <a:chExt cx="9144000" cy="5143500"/>
+        </a:xfrm>
+      </p:grpSpPr>
       <p:sp>
         <p:nvSpPr>
           <p:cNvPr id="2" name="Rectangle 1"/>
@@ -4763,8 +4784,8 @@
         </p:nvSpPr>
         <p:spPr>
           <a:xfrm>
-            <a:off x="457200" y="566928"/>
-            <a:ext cx="8229600" cy="640080"/>
+            <a:off x="457200" y="502920"/>
+            <a:ext cx="8229600" cy="502920"/>
           </a:xfrm>
           <a:prstGeom prst="rect">
             <a:avLst/>
@@ -4779,7 +4800,7 @@
           <a:p>
             <a:pPr algn="l"/>
             <a:r>
-              <a:rPr sz="3400" b="1" i="0">
+              <a:rPr sz="2800" b="1" i="0">
                 <a:solidFill>
                   <a:srgbClr val="F0F0F0"/>
                 </a:solidFill>
@@ -4798,7 +4819,7 @@
         </p:nvSpPr>
         <p:spPr>
           <a:xfrm>
-            <a:off x="365760" y="1371600"/>
+            <a:off x="365760" y="1188720"/>
             <a:ext cx="1828800" cy="1005840"/>
           </a:xfrm>
           <a:prstGeom prst="rect">
@@ -4843,7 +4864,7 @@
         </p:nvSpPr>
         <p:spPr>
           <a:xfrm>
-            <a:off x="365760" y="1426464"/>
+            <a:off x="365760" y="1243584"/>
             <a:ext cx="1828800" cy="512064"/>
           </a:xfrm>
           <a:prstGeom prst="rect">
@@ -4878,7 +4899,7 @@
         </p:nvSpPr>
         <p:spPr>
           <a:xfrm>
-            <a:off x="365760" y="1993392"/>
+            <a:off x="365760" y="1810512"/>
             <a:ext cx="1828800" cy="292608"/>
           </a:xfrm>
           <a:prstGeom prst="rect">
@@ -4913,7 +4934,7 @@
         </p:nvSpPr>
         <p:spPr>
           <a:xfrm>
-            <a:off x="2286000" y="1371600"/>
+            <a:off x="2286000" y="1188720"/>
             <a:ext cx="1828800" cy="1005840"/>
           </a:xfrm>
           <a:prstGeom prst="rect">
@@ -4958,7 +4979,7 @@
         </p:nvSpPr>
         <p:spPr>
           <a:xfrm>
-            <a:off x="2286000" y="1426464"/>
+            <a:off x="2286000" y="1243584"/>
             <a:ext cx="1828800" cy="512064"/>
           </a:xfrm>
           <a:prstGeom prst="rect">
@@ -4993,7 +5014,7 @@
         </p:nvSpPr>
         <p:spPr>
           <a:xfrm>
-            <a:off x="2286000" y="1993392"/>
+            <a:off x="2286000" y="1810512"/>
             <a:ext cx="1828800" cy="292608"/>
           </a:xfrm>
           <a:prstGeom prst="rect">
@@ -5028,7 +5049,7 @@
         </p:nvSpPr>
         <p:spPr>
           <a:xfrm>
-            <a:off x="4206240" y="1371600"/>
+            <a:off x="4206240" y="1188720"/>
             <a:ext cx="1828800" cy="1005840"/>
           </a:xfrm>
           <a:prstGeom prst="rect">
@@ -5073,7 +5094,7 @@
         </p:nvSpPr>
         <p:spPr>
           <a:xfrm>
-            <a:off x="4206240" y="1426464"/>
+            <a:off x="4206240" y="1243584"/>
             <a:ext cx="1828800" cy="512064"/>
           </a:xfrm>
           <a:prstGeom prst="rect">
@@ -5108,7 +5129,7 @@
         </p:nvSpPr>
         <p:spPr>
           <a:xfrm>
-            <a:off x="4206240" y="1993392"/>
+            <a:off x="4206240" y="1810512"/>
             <a:ext cx="1828800" cy="292608"/>
           </a:xfrm>
           <a:prstGeom prst="rect">
@@ -5143,7 +5164,7 @@
         </p:nvSpPr>
         <p:spPr>
           <a:xfrm>
-            <a:off x="6126480" y="1371600"/>
+            <a:off x="6126480" y="1188720"/>
             <a:ext cx="1828800" cy="1005840"/>
           </a:xfrm>
           <a:prstGeom prst="rect">
@@ -5188,7 +5209,7 @@
         </p:nvSpPr>
         <p:spPr>
           <a:xfrm>
-            <a:off x="6126480" y="1426464"/>
+            <a:off x="6126480" y="1243584"/>
             <a:ext cx="1828800" cy="512064"/>
           </a:xfrm>
           <a:prstGeom prst="rect">
@@ -5223,7 +5244,7 @@
         </p:nvSpPr>
         <p:spPr>
           <a:xfrm>
-            <a:off x="6126480" y="1993392"/>
+            <a:off x="6126480" y="1810512"/>
             <a:ext cx="1828800" cy="292608"/>
           </a:xfrm>
           <a:prstGeom prst="rect">

</xml_diff>

<commit_message>
fix(pptx): update build duration to 2 weeks across slides 1 and 3
Corrects the stat card on slide 3 (1 week → 2 weeks to ship) and the
duration badge on slide 1 (1 WEEK → 2 WEEKS) to reflect the actual
build timeline.

Co-Authored-By: Claude Sonnet 4.6 <noreply@anthropic.com>
</commit_message>
<xml_diff>
--- a/docs/task01-presentation.pptx
+++ b/docs/task01-presentation.pptx
@@ -3223,7 +3223,7 @@
                 </a:solidFill>
                 <a:latin typeface="Calibri"/>
               </a:rPr>
-              <a:t>1 WEEK  ·  DUE APR 4</a:t>
+              <a:t>2 WEEKS  ·  DUE APR 4</a:t>
             </a:r>
           </a:p>
         </p:txBody>
@@ -5116,7 +5116,7 @@
                 </a:solidFill>
                 <a:latin typeface="Georgia"/>
               </a:rPr>
-              <a:t>1</a:t>
+              <a:t>2</a:t>
             </a:r>
           </a:p>
         </p:txBody>
@@ -5151,7 +5151,7 @@
                 </a:solidFill>
                 <a:latin typeface="Calibri"/>
               </a:rPr>
-              <a:t>week to ship</a:t>
+              <a:t>weeks to ship</a:t>
             </a:r>
           </a:p>
         </p:txBody>

</xml_diff>